<commit_message>
feat: add retrospective consent evidence
</commit_message>
<xml_diff>
--- a/docs/research/poster/ssrp_consent_longitudinal_poster_2026-07-29.pptx
+++ b/docs/research/poster/ssrp_consent_longitudinal_poster_2026-07-29.pptx
@@ -2,13 +2,13 @@
 <file path=ppt/presentation.xml><?xml version="1.0" encoding="utf-8"?>
 <p:presentation xmlns:p="http://schemas.openxmlformats.org/presentationml/2006/main">
   <p:sldMasterIdLst>
-    <p:sldMasterId xmlns:r="http://schemas.openxmlformats.org/officeDocument/2006/relationships" id="2147483648" r:id="Rdc0cc5c365cd4c87"/>
+    <p:sldMasterId xmlns:r="http://schemas.openxmlformats.org/officeDocument/2006/relationships" id="2147483648" r:id="R5ee641337bf1431b"/>
   </p:sldMasterIdLst>
   <p:notesMasterIdLst>
-    <p:notesMasterId xmlns:r="http://schemas.openxmlformats.org/officeDocument/2006/relationships" r:id="R7dc803fddcfa4b41"/>
+    <p:notesMasterId xmlns:r="http://schemas.openxmlformats.org/officeDocument/2006/relationships" r:id="Re8d446c4212040e1"/>
   </p:notesMasterIdLst>
   <p:sldIdLst>
-    <p:sldId xmlns:r="http://schemas.openxmlformats.org/officeDocument/2006/relationships" id="256" r:id="Ra04969bb6b384780"/>
+    <p:sldId xmlns:r="http://schemas.openxmlformats.org/officeDocument/2006/relationships" id="256" r:id="Ree470578594d4084"/>
   </p:sldIdLst>
   <p:sldSz cx="43891200" cy="32918400"/>
   <p:notesSz cx="6858000" cy="9144000"/>
@@ -442,52 +442,52 @@
           <a:lstStyle xmlns:a="http://schemas.openxmlformats.org/drawingml/2006/main"/>
           <a:p xmlns:a="http://schemas.openxmlformats.org/drawingml/2006/main">
             <a:r>
-              <a:t>The poster is organized left-to-right: question and measure, matched longitudinal design, pilot result and next study. The one-interval limitation is explicit.</a:t>
-            </a:r>
-          </a:p>
-          <a:p xmlns:a="http://schemas.openxmlformats.org/drawingml/2006/main">
-            <a:r>
-              <a:t/>
-            </a:r>
-          </a:p>
-          <a:p xmlns:a="http://schemas.openxmlformats.org/drawingml/2006/main">
-            <a:r>
               <a:t>[Sources]</a:t>
             </a:r>
           </a:p>
           <a:p xmlns:a="http://schemas.openxmlformats.org/drawingml/2006/main">
             <a:r>
-              <a:t>- https://case.edu/studentlife/ugresearch/share-your-work/intersections-poster-symposium/preparing-intersections</a:t>
-            </a:r>
-          </a:p>
-          <a:p xmlns:a="http://schemas.openxmlformats.org/drawingml/2006/main">
-            <a:r>
-              <a:t>- https://case.edu/studentlife/ugresearch/sites/default/files/2022-12/SOURCE_%20Improving%20Presentation%20Skills.pptx%20%281%29.pdf</a:t>
-            </a:r>
-          </a:p>
-          <a:p xmlns:a="http://schemas.openxmlformats.org/drawingml/2006/main">
-            <a:r>
-              <a:t>- data/research_package/audit_report_summary.csv</a:t>
-            </a:r>
-          </a:p>
-          <a:p xmlns:a="http://schemas.openxmlformats.org/drawingml/2006/main">
-            <a:r>
-              <a:t>- data/research_package/longitudinal_summary.csv</a:t>
-            </a:r>
-          </a:p>
-          <a:p xmlns:a="http://schemas.openxmlformats.org/drawingml/2006/main">
-            <a:r>
-              <a:t>- data/longitudinal_directional_review_2026-07-29.csv</a:t>
-            </a:r>
-          </a:p>
-          <a:p xmlns:a="http://schemas.openxmlformats.org/drawingml/2006/main">
-            <a:r>
-              <a:t>- docs/research/june14_capture_attempt_audit_2026-06-14.md</a:t>
-            </a:r>
-          </a:p>
-          <a:p xmlns:a="http://schemas.openxmlformats.org/drawingml/2006/main">
-            <a:r>
-              <a:t>- docs/research/june15_coca_cola_smoke_audit_2026-06-15.md</a:t>
+              <a:t>- https://www.legifrance.gouv.fr/cnil/id/CNILTEXT000044840062</a:t>
+            </a:r>
+          </a:p>
+          <a:p xmlns:a="http://schemas.openxmlformats.org/drawingml/2006/main">
+            <a:r>
+              <a:t>- https://blog.google/company-news/inside-google/around-the-globe/google-europe/new-cookie-choices-in-europe/</a:t>
+            </a:r>
+          </a:p>
+          <a:p xmlns:a="http://schemas.openxmlformats.org/drawingml/2006/main">
+            <a:r>
+              <a:t>- https://www.legifrance.gouv.fr/cnil/id/CNILTEXT000044840532</a:t>
+            </a:r>
+          </a:p>
+          <a:p xmlns:a="http://schemas.openxmlformats.org/drawingml/2006/main">
+            <a:r>
+              <a:t>- https://www.legifrance.gouv.fr/cnil/id/CNILTEXT000046096716</a:t>
+            </a:r>
+          </a:p>
+          <a:p xmlns:a="http://schemas.openxmlformats.org/drawingml/2006/main">
+            <a:r>
+              <a:t>- https://www.legifrance.gouv.fr/cnil/id/CNILTEXT000046977994/</a:t>
+            </a:r>
+          </a:p>
+          <a:p xmlns:a="http://schemas.openxmlformats.org/drawingml/2006/main">
+            <a:r>
+              <a:t>- https://www.cnil.fr/en/closure-injunction-issued-against-orange</a:t>
+            </a:r>
+          </a:p>
+          <a:p xmlns:a="http://schemas.openxmlformats.org/drawingml/2006/main">
+            <a:r>
+              <a:t>- https://www.cnil.fr/en/cookies-placed-without-consent-company-publishes-website-vanityfairfr-fined-750000-euros</a:t>
+            </a:r>
+          </a:p>
+          <a:p xmlns:a="http://schemas.openxmlformats.org/drawingml/2006/main">
+            <a:r>
+              <a:t>- https://arxiv.org/abs/2606.31485</a:t>
+            </a:r>
+          </a:p>
+          <a:p xmlns:a="http://schemas.openxmlformats.org/drawingml/2006/main">
+            <a:r>
+              <a:t>- Internal: data/retrospective_source_registry_2026-07-29.csv</a:t>
             </a:r>
           </a:p>
         </p:txBody>
@@ -555,7 +555,7 @@
   </p:cSld>
   <p:clrMap bg1="lt1" tx1="dk1" bg2="lt2" tx2="dk2" accent1="accent1" accent2="accent2" accent3="accent3" accent4="accent4" accent5="accent5" accent6="accent6" hlink="hlink" folHlink="folHlink"/>
   <p:sldLayoutIdLst>
-    <p:sldLayoutId xmlns:r="http://schemas.openxmlformats.org/officeDocument/2006/relationships" id="2147483649" r:id="Rb184c8ac4f954fe2"/>
+    <p:sldLayoutId xmlns:r="http://schemas.openxmlformats.org/officeDocument/2006/relationships" id="2147483649" r:id="Rd37c2a93a3364d7f"/>
   </p:sldLayoutIdLst>
   <p:txStyles>
     <p:titleStyle>
@@ -1167,6 +1167,7 @@
           <a:lstStyle xmlns:a="http://schemas.openxmlformats.org/drawingml/2006/main"/>
           <a:p xmlns:a="http://schemas.openxmlformats.org/drawingml/2006/main">
             <a:pPr algn="l">
+              <a:buNone/>
               <a:defRPr sz="2100" b="1" i="0">
                 <a:solidFill>
                   <a:srgbClr val="DDF2FA"/>
@@ -1223,6 +1224,7 @@
           <a:lstStyle xmlns:a="http://schemas.openxmlformats.org/drawingml/2006/main"/>
           <a:p xmlns:a="http://schemas.openxmlformats.org/drawingml/2006/main">
             <a:pPr algn="l">
+              <a:buNone/>
               <a:defRPr sz="7050" b="1" i="0">
                 <a:solidFill>
                   <a:srgbClr val="FFFFFF"/>
@@ -1241,7 +1243,7 @@
                 <a:ea typeface="Arial"/>
                 <a:cs typeface="Arial"/>
               </a:rPr>
-              <a:t>Tracking How Consent Interfaces Evolve</a:t>
+              <a:t>How Cookie Consent Interfaces Changed</a:t>
             </a:r>
           </a:p>
         </p:txBody>
@@ -1279,6 +1281,7 @@
           <a:lstStyle xmlns:a="http://schemas.openxmlformats.org/drawingml/2006/main"/>
           <a:p xmlns:a="http://schemas.openxmlformats.org/drawingml/2006/main">
             <a:pPr algn="l">
+              <a:buNone/>
               <a:defRPr sz="2850" b="0" i="0">
                 <a:solidFill>
                   <a:srgbClr val="D9E0E5"/>
@@ -1297,7 +1300,7 @@
                 <a:ea typeface="Arial"/>
                 <a:cs typeface="Arial"/>
               </a:rPr>
-              <a:t>A repeatable, evidence-linked framework for comparing the same website over time</a:t>
+              <a:t>A controlled capture method plus five dated company trajectories from primary sources</a:t>
             </a:r>
           </a:p>
         </p:txBody>
@@ -1335,6 +1338,7 @@
           <a:lstStyle xmlns:a="http://schemas.openxmlformats.org/drawingml/2006/main"/>
           <a:p xmlns:a="http://schemas.openxmlformats.org/drawingml/2006/main">
             <a:pPr algn="l">
+              <a:buNone/>
               <a:defRPr sz="2025" b="0" i="0">
                 <a:solidFill>
                   <a:srgbClr val="BAC4CB"/>
@@ -1391,6 +1395,7 @@
           <a:lstStyle xmlns:a="http://schemas.openxmlformats.org/drawingml/2006/main"/>
           <a:p xmlns:a="http://schemas.openxmlformats.org/drawingml/2006/main">
             <a:pPr algn="l">
+              <a:buNone/>
               <a:defRPr sz="2325" b="1" i="0">
                 <a:solidFill>
                   <a:srgbClr val="66C6E9"/>
@@ -1447,6 +1452,7 @@
           <a:lstStyle xmlns:a="http://schemas.openxmlformats.org/drawingml/2006/main"/>
           <a:p xmlns:a="http://schemas.openxmlformats.org/drawingml/2006/main">
             <a:pPr algn="l">
+              <a:buNone/>
               <a:defRPr sz="2025" b="1" i="0">
                 <a:solidFill>
                   <a:srgbClr val="FFFFFF"/>
@@ -1465,7 +1471,7 @@
                 <a:ea typeface="Arial"/>
                 <a:cs typeface="Arial"/>
               </a:rPr>
-              <a:t>repeatable measure</a:t>
+              <a:t>component rubric</a:t>
             </a:r>
           </a:p>
         </p:txBody>
@@ -1503,6 +1509,7 @@
           <a:lstStyle xmlns:a="http://schemas.openxmlformats.org/drawingml/2006/main"/>
           <a:p xmlns:a="http://schemas.openxmlformats.org/drawingml/2006/main">
             <a:pPr algn="l">
+              <a:buNone/>
               <a:defRPr sz="2325" b="1" i="0">
                 <a:solidFill>
                   <a:srgbClr val="66C6E9"/>
@@ -1559,6 +1566,7 @@
           <a:lstStyle xmlns:a="http://schemas.openxmlformats.org/drawingml/2006/main"/>
           <a:p xmlns:a="http://schemas.openxmlformats.org/drawingml/2006/main">
             <a:pPr algn="l">
+              <a:buNone/>
               <a:defRPr sz="2025" b="1" i="0">
                 <a:solidFill>
                   <a:srgbClr val="FFFFFF"/>
@@ -1577,7 +1585,7 @@
                 <a:ea typeface="Arial"/>
                 <a:cs typeface="Arial"/>
               </a:rPr>
-              <a:t>matched versions</a:t>
+              <a:t>dated trajectories</a:t>
             </a:r>
           </a:p>
         </p:txBody>
@@ -1615,6 +1623,7 @@
           <a:lstStyle xmlns:a="http://schemas.openxmlformats.org/drawingml/2006/main"/>
           <a:p xmlns:a="http://schemas.openxmlformats.org/drawingml/2006/main">
             <a:pPr algn="l">
+              <a:buNone/>
               <a:defRPr sz="2325" b="1" i="0">
                 <a:solidFill>
                   <a:srgbClr val="66C6E9"/>
@@ -1671,6 +1680,7 @@
           <a:lstStyle xmlns:a="http://schemas.openxmlformats.org/drawingml/2006/main"/>
           <a:p xmlns:a="http://schemas.openxmlformats.org/drawingml/2006/main">
             <a:pPr algn="l">
+              <a:buNone/>
               <a:defRPr sz="2025" b="1" i="0">
                 <a:solidFill>
                   <a:srgbClr val="FFFFFF"/>
@@ -1689,7 +1699,7 @@
                 <a:ea typeface="Arial"/>
                 <a:cs typeface="Arial"/>
               </a:rPr>
-              <a:t>validated trajectory</a:t>
+              <a:t>4 improved | 1 regressed</a:t>
             </a:r>
           </a:p>
         </p:txBody>
@@ -1727,6 +1737,7 @@
           <a:lstStyle xmlns:a="http://schemas.openxmlformats.org/drawingml/2006/main"/>
           <a:p xmlns:a="http://schemas.openxmlformats.org/drawingml/2006/main">
             <a:pPr algn="l">
+              <a:buNone/>
               <a:defRPr sz="1800" b="0" i="0">
                 <a:solidFill>
                   <a:srgbClr val="D9E0E5"/>
@@ -1745,7 +1756,7 @@
                 <a:ea typeface="Arial"/>
                 <a:cs typeface="Arial"/>
               </a:rPr>
-              <a:t>improved | regressed | mixed | stable | insufficient</a:t>
+              <a:t>direction is separated from causal evidence strength</a:t>
             </a:r>
           </a:p>
         </p:txBody>
@@ -1816,6 +1827,7 @@
           <a:lstStyle xmlns:a="http://schemas.openxmlformats.org/drawingml/2006/main"/>
           <a:p xmlns:a="http://schemas.openxmlformats.org/drawingml/2006/main">
             <a:pPr algn="l">
+              <a:buNone/>
               <a:defRPr sz="2025" b="1" i="0">
                 <a:solidFill>
                   <a:srgbClr val="146EA8"/>
@@ -1872,6 +1884,7 @@
           <a:lstStyle xmlns:a="http://schemas.openxmlformats.org/drawingml/2006/main"/>
           <a:p xmlns:a="http://schemas.openxmlformats.org/drawingml/2006/main">
             <a:pPr algn="l">
+              <a:buNone/>
               <a:defRPr sz="2700" b="1" i="0">
                 <a:solidFill>
                   <a:srgbClr val="101820"/>
@@ -1890,7 +1903,7 @@
                 <a:ea typeface="Arial"/>
                 <a:cs typeface="Arial"/>
               </a:rPr>
-              <a:t>RQ1 defines the ruler. RQ2 repeats the measurement. Evidence review determines whether a change has direction.</a:t>
+              <a:t>Concrete interactions improved under regulatory pressure, but consent quality remained component-specific and reversible.</a:t>
             </a:r>
           </a:p>
         </p:txBody>
@@ -1928,6 +1941,7 @@
           <a:lstStyle xmlns:a="http://schemas.openxmlformats.org/drawingml/2006/main"/>
           <a:p xmlns:a="http://schemas.openxmlformats.org/drawingml/2006/main">
             <a:pPr algn="l">
+              <a:buNone/>
               <a:defRPr sz="2100" b="1" i="0">
                 <a:solidFill>
                   <a:srgbClr val="146EA8"/>
@@ -1984,6 +1998,7 @@
           <a:lstStyle xmlns:a="http://schemas.openxmlformats.org/drawingml/2006/main"/>
           <a:p xmlns:a="http://schemas.openxmlformats.org/drawingml/2006/main">
             <a:pPr algn="l">
+              <a:buNone/>
               <a:defRPr sz="2625" b="1" i="0">
                 <a:solidFill>
                   <a:srgbClr val="146EA8"/>
@@ -2073,6 +2088,7 @@
           <a:lstStyle xmlns:a="http://schemas.openxmlformats.org/drawingml/2006/main"/>
           <a:p xmlns:a="http://schemas.openxmlformats.org/drawingml/2006/main">
             <a:pPr algn="l">
+              <a:buNone/>
               <a:defRPr sz="2550" b="1" i="0">
                 <a:solidFill>
                   <a:srgbClr val="101820"/>
@@ -2091,7 +2107,7 @@
                 <a:ea typeface="Arial"/>
                 <a:cs typeface="Arial"/>
               </a:rPr>
-              <a:t>A snapshot can describe one consent interface. It cannot show how that interface evolves.</a:t>
+              <a:t>How did consent interfaces change over time, and what evidence can explain the direction?</a:t>
             </a:r>
           </a:p>
         </p:txBody>
@@ -2129,6 +2145,7 @@
           <a:lstStyle xmlns:a="http://schemas.openxmlformats.org/drawingml/2006/main"/>
           <a:p xmlns:a="http://schemas.openxmlformats.org/drawingml/2006/main">
             <a:pPr algn="l">
+              <a:buNone/>
               <a:defRPr sz="2175" b="0" i="0">
                 <a:solidFill>
                   <a:srgbClr val="4C5B67"/>
@@ -2147,7 +2164,7 @@
                 <a:ea typeface="Arial"/>
                 <a:cs typeface="Arial"/>
               </a:rPr>
-              <a:t>The study compares repeated observations of the same site and asks whether user choice became easier, clearer, more balanced, or worse.</a:t>
+              <a:t>RQ1 codes user choice by component. RQ2 compares dated states while keeping direction separate from cause.</a:t>
             </a:r>
           </a:p>
         </p:txBody>
@@ -2185,6 +2202,7 @@
           <a:lstStyle xmlns:a="http://schemas.openxmlformats.org/drawingml/2006/main"/>
           <a:p xmlns:a="http://schemas.openxmlformats.org/drawingml/2006/main">
             <a:pPr algn="l">
+              <a:buNone/>
               <a:defRPr sz="2400" b="1" i="0">
                 <a:solidFill>
                   <a:srgbClr val="146EA8"/>
@@ -2203,7 +2221,7 @@
                 <a:ea typeface="Arial"/>
                 <a:cs typeface="Arial"/>
               </a:rPr>
-              <a:t>RQ1: the repeatable ruler</a:t>
+              <a:t>RQ1: the component ruler</a:t>
             </a:r>
           </a:p>
         </p:txBody>
@@ -2274,6 +2292,7 @@
           <a:lstStyle xmlns:a="http://schemas.openxmlformats.org/drawingml/2006/main"/>
           <a:p xmlns:a="http://schemas.openxmlformats.org/drawingml/2006/main">
             <a:pPr algn="l">
+              <a:buNone/>
               <a:defRPr sz="2325" b="1" i="0">
                 <a:solidFill>
                   <a:srgbClr val="101820"/>
@@ -2330,6 +2349,7 @@
           <a:lstStyle xmlns:a="http://schemas.openxmlformats.org/drawingml/2006/main"/>
           <a:p xmlns:a="http://schemas.openxmlformats.org/drawingml/2006/main">
             <a:pPr algn="l">
+              <a:buNone/>
               <a:defRPr sz="2025" b="0" i="0">
                 <a:solidFill>
                   <a:srgbClr val="4C5B67"/>
@@ -2419,6 +2439,7 @@
           <a:lstStyle xmlns:a="http://schemas.openxmlformats.org/drawingml/2006/main"/>
           <a:p xmlns:a="http://schemas.openxmlformats.org/drawingml/2006/main">
             <a:pPr algn="l">
+              <a:buNone/>
               <a:defRPr sz="2325" b="1" i="0">
                 <a:solidFill>
                   <a:srgbClr val="101820"/>
@@ -2475,6 +2496,7 @@
           <a:lstStyle xmlns:a="http://schemas.openxmlformats.org/drawingml/2006/main"/>
           <a:p xmlns:a="http://schemas.openxmlformats.org/drawingml/2006/main">
             <a:pPr algn="l">
+              <a:buNone/>
               <a:defRPr sz="2025" b="0" i="0">
                 <a:solidFill>
                   <a:srgbClr val="4C5B67"/>
@@ -2564,6 +2586,7 @@
           <a:lstStyle xmlns:a="http://schemas.openxmlformats.org/drawingml/2006/main"/>
           <a:p xmlns:a="http://schemas.openxmlformats.org/drawingml/2006/main">
             <a:pPr algn="l">
+              <a:buNone/>
               <a:defRPr sz="2325" b="1" i="0">
                 <a:solidFill>
                   <a:srgbClr val="101820"/>
@@ -2620,6 +2643,7 @@
           <a:lstStyle xmlns:a="http://schemas.openxmlformats.org/drawingml/2006/main"/>
           <a:p xmlns:a="http://schemas.openxmlformats.org/drawingml/2006/main">
             <a:pPr algn="l">
+              <a:buNone/>
               <a:defRPr sz="2025" b="0" i="0">
                 <a:solidFill>
                   <a:srgbClr val="4C5B67"/>
@@ -2709,6 +2733,7 @@
           <a:lstStyle xmlns:a="http://schemas.openxmlformats.org/drawingml/2006/main"/>
           <a:p xmlns:a="http://schemas.openxmlformats.org/drawingml/2006/main">
             <a:pPr algn="l">
+              <a:buNone/>
               <a:defRPr sz="2325" b="1" i="0">
                 <a:solidFill>
                   <a:srgbClr val="101820"/>
@@ -2727,7 +2752,7 @@
                 <a:ea typeface="Arial"/>
                 <a:cs typeface="Arial"/>
               </a:rPr>
-              <a:t>Unbiased choice</a:t>
+              <a:t>Choice + effectiveness</a:t>
             </a:r>
           </a:p>
         </p:txBody>
@@ -2765,6 +2790,7 @@
           <a:lstStyle xmlns:a="http://schemas.openxmlformats.org/drawingml/2006/main"/>
           <a:p xmlns:a="http://schemas.openxmlformats.org/drawingml/2006/main">
             <a:pPr algn="l">
+              <a:buNone/>
               <a:defRPr sz="2025" b="0" i="0">
                 <a:solidFill>
                   <a:srgbClr val="4C5B67"/>
@@ -2783,7 +2809,7 @@
                 <a:ea typeface="Arial"/>
                 <a:cs typeface="Arial"/>
               </a:rPr>
-              <a:t>Are options visually and structurally balanced?</a:t>
+              <a:t>Are options balanced, and does refusal stop tracking?</a:t>
             </a:r>
           </a:p>
         </p:txBody>
@@ -2821,6 +2847,7 @@
           <a:lstStyle xmlns:a="http://schemas.openxmlformats.org/drawingml/2006/main"/>
           <a:p xmlns:a="http://schemas.openxmlformats.org/drawingml/2006/main">
             <a:pPr algn="l">
+              <a:buNone/>
               <a:defRPr sz="2400" b="1" i="0">
                 <a:solidFill>
                   <a:srgbClr val="146EA8"/>
@@ -2912,6 +2939,7 @@
           <a:lstStyle xmlns:a="http://schemas.openxmlformats.org/drawingml/2006/main"/>
           <a:p xmlns:a="http://schemas.openxmlformats.org/drawingml/2006/main">
             <a:pPr algn="ctr">
+              <a:buNone/>
               <a:defRPr sz="1650" b="1" i="0">
                 <a:solidFill>
                   <a:srgbClr val="18867F"/>
@@ -2968,6 +2996,7 @@
           <a:lstStyle xmlns:a="http://schemas.openxmlformats.org/drawingml/2006/main"/>
           <a:p xmlns:a="http://schemas.openxmlformats.org/drawingml/2006/main">
             <a:pPr algn="l">
+              <a:buNone/>
               <a:defRPr sz="1800" b="0" i="0">
                 <a:solidFill>
                   <a:srgbClr val="101820"/>
@@ -3059,6 +3088,7 @@
           <a:lstStyle xmlns:a="http://schemas.openxmlformats.org/drawingml/2006/main"/>
           <a:p xmlns:a="http://schemas.openxmlformats.org/drawingml/2006/main">
             <a:pPr algn="ctr">
+              <a:buNone/>
               <a:defRPr sz="1650" b="1" i="0">
                 <a:solidFill>
                   <a:srgbClr val="A13B16"/>
@@ -3115,6 +3145,7 @@
           <a:lstStyle xmlns:a="http://schemas.openxmlformats.org/drawingml/2006/main"/>
           <a:p xmlns:a="http://schemas.openxmlformats.org/drawingml/2006/main">
             <a:pPr algn="l">
+              <a:buNone/>
               <a:defRPr sz="1800" b="0" i="0">
                 <a:solidFill>
                   <a:srgbClr val="101820"/>
@@ -3206,6 +3237,7 @@
           <a:lstStyle xmlns:a="http://schemas.openxmlformats.org/drawingml/2006/main"/>
           <a:p xmlns:a="http://schemas.openxmlformats.org/drawingml/2006/main">
             <a:pPr algn="ctr">
+              <a:buNone/>
               <a:defRPr sz="1650" b="1" i="0">
                 <a:solidFill>
                   <a:srgbClr val="101820"/>
@@ -3262,6 +3294,7 @@
           <a:lstStyle xmlns:a="http://schemas.openxmlformats.org/drawingml/2006/main"/>
           <a:p xmlns:a="http://schemas.openxmlformats.org/drawingml/2006/main">
             <a:pPr algn="l">
+              <a:buNone/>
               <a:defRPr sz="1800" b="0" i="0">
                 <a:solidFill>
                   <a:srgbClr val="101820"/>
@@ -3353,6 +3386,7 @@
           <a:lstStyle xmlns:a="http://schemas.openxmlformats.org/drawingml/2006/main"/>
           <a:p xmlns:a="http://schemas.openxmlformats.org/drawingml/2006/main">
             <a:pPr algn="ctr">
+              <a:buNone/>
               <a:defRPr sz="1650" b="1" i="0">
                 <a:solidFill>
                   <a:srgbClr val="146EA8"/>
@@ -3409,6 +3443,7 @@
           <a:lstStyle xmlns:a="http://schemas.openxmlformats.org/drawingml/2006/main"/>
           <a:p xmlns:a="http://schemas.openxmlformats.org/drawingml/2006/main">
             <a:pPr algn="l">
+              <a:buNone/>
               <a:defRPr sz="1800" b="0" i="0">
                 <a:solidFill>
                   <a:srgbClr val="101820"/>
@@ -3500,6 +3535,7 @@
           <a:lstStyle xmlns:a="http://schemas.openxmlformats.org/drawingml/2006/main"/>
           <a:p xmlns:a="http://schemas.openxmlformats.org/drawingml/2006/main">
             <a:pPr algn="ctr">
+              <a:buNone/>
               <a:defRPr sz="1650" b="1" i="0">
                 <a:solidFill>
                   <a:srgbClr val="4C5B67"/>
@@ -3556,6 +3592,7 @@
           <a:lstStyle xmlns:a="http://schemas.openxmlformats.org/drawingml/2006/main"/>
           <a:p xmlns:a="http://schemas.openxmlformats.org/drawingml/2006/main">
             <a:pPr algn="l">
+              <a:buNone/>
               <a:defRPr sz="1800" b="0" i="0">
                 <a:solidFill>
                   <a:srgbClr val="101820"/>
@@ -3645,6 +3682,7 @@
           <a:lstStyle xmlns:a="http://schemas.openxmlformats.org/drawingml/2006/main"/>
           <a:p xmlns:a="http://schemas.openxmlformats.org/drawingml/2006/main">
             <a:pPr algn="l">
+              <a:buNone/>
               <a:defRPr sz="1875" b="1" i="0">
                 <a:solidFill>
                   <a:srgbClr val="A13B16"/>
@@ -3663,7 +3701,7 @@
                 <a:ea typeface="Arial"/>
                 <a:cs typeface="Arial"/>
               </a:rPr>
-              <a:t>Guardrail</a:t>
+              <a:t>Claim guardrail</a:t>
             </a:r>
           </a:p>
         </p:txBody>
@@ -3701,6 +3739,7 @@
           <a:lstStyle xmlns:a="http://schemas.openxmlformats.org/drawingml/2006/main"/>
           <a:p xmlns:a="http://schemas.openxmlformats.org/drawingml/2006/main">
             <a:pPr algn="l">
+              <a:buNone/>
               <a:defRPr sz="2100" b="1" i="0">
                 <a:solidFill>
                   <a:srgbClr val="101820"/>
@@ -3719,7 +3758,7 @@
                 <a:ea typeface="Arial"/>
                 <a:cs typeface="Arial"/>
               </a:rPr>
-              <a:t>Copy, DOM, layout, and image hashes trigger review. They do not show improvement or regression by themselves.</a:t>
+              <a:t>Every direction needs dated before/after evidence. Every causal claim receives a separate strength label.</a:t>
             </a:r>
           </a:p>
         </p:txBody>
@@ -3757,6 +3796,7 @@
           <a:lstStyle xmlns:a="http://schemas.openxmlformats.org/drawingml/2006/main"/>
           <a:p xmlns:a="http://schemas.openxmlformats.org/drawingml/2006/main">
             <a:pPr algn="l">
+              <a:buNone/>
               <a:defRPr sz="2100" b="1" i="0">
                 <a:solidFill>
                   <a:srgbClr val="146EA8"/>
@@ -3813,6 +3853,7 @@
           <a:lstStyle xmlns:a="http://schemas.openxmlformats.org/drawingml/2006/main"/>
           <a:p xmlns:a="http://schemas.openxmlformats.org/drawingml/2006/main">
             <a:pPr algn="l">
+              <a:buNone/>
               <a:defRPr sz="2625" b="1" i="0">
                 <a:solidFill>
                   <a:srgbClr val="146EA8"/>
@@ -3831,7 +3872,7 @@
                 <a:ea typeface="Arial"/>
                 <a:cs typeface="Arial"/>
               </a:rPr>
-              <a:t>MATCHED LONGITUDINAL DESIGN</a:t>
+              <a:t>TWO EVIDENCE LANES</a:t>
             </a:r>
           </a:p>
         </p:txBody>
@@ -3902,6 +3943,7 @@
           <a:lstStyle xmlns:a="http://schemas.openxmlformats.org/drawingml/2006/main"/>
           <a:p xmlns:a="http://schemas.openxmlformats.org/drawingml/2006/main">
             <a:pPr algn="ctr">
+              <a:buNone/>
               <a:defRPr sz="2700" b="1" i="0">
                 <a:solidFill>
                   <a:srgbClr val="101820"/>
@@ -3920,7 +3962,7 @@
                 <a:ea typeface="Arial"/>
                 <a:cs typeface="Arial"/>
               </a:rPr>
-              <a:t>Same site + same context + same ruler</a:t>
+              <a:t>Controlled local capture + source-complete retrospective cases</a:t>
             </a:r>
           </a:p>
         </p:txBody>
@@ -4024,6 +4066,7 @@
           <a:lstStyle xmlns:a="http://schemas.openxmlformats.org/drawingml/2006/main"/>
           <a:p xmlns:a="http://schemas.openxmlformats.org/drawingml/2006/main">
             <a:pPr algn="ctr">
+              <a:buNone/>
               <a:defRPr sz="2025" b="1" i="0">
                 <a:solidFill>
                   <a:srgbClr val="FFFFFF"/>
@@ -4080,6 +4123,7 @@
           <a:lstStyle xmlns:a="http://schemas.openxmlformats.org/drawingml/2006/main"/>
           <a:p xmlns:a="http://schemas.openxmlformats.org/drawingml/2006/main">
             <a:pPr algn="ctr">
+              <a:buNone/>
               <a:defRPr sz="1875" b="1" i="0">
                 <a:solidFill>
                   <a:srgbClr val="101820"/>
@@ -4169,6 +4213,7 @@
           <a:lstStyle xmlns:a="http://schemas.openxmlformats.org/drawingml/2006/main"/>
           <a:p xmlns:a="http://schemas.openxmlformats.org/drawingml/2006/main">
             <a:pPr algn="ctr">
+              <a:buNone/>
               <a:defRPr sz="2025" b="1" i="0">
                 <a:solidFill>
                   <a:srgbClr val="FFFFFF"/>
@@ -4225,6 +4270,7 @@
           <a:lstStyle xmlns:a="http://schemas.openxmlformats.org/drawingml/2006/main"/>
           <a:p xmlns:a="http://schemas.openxmlformats.org/drawingml/2006/main">
             <a:pPr algn="ctr">
+              <a:buNone/>
               <a:defRPr sz="1875" b="1" i="0">
                 <a:solidFill>
                   <a:srgbClr val="101820"/>
@@ -4314,6 +4360,7 @@
           <a:lstStyle xmlns:a="http://schemas.openxmlformats.org/drawingml/2006/main"/>
           <a:p xmlns:a="http://schemas.openxmlformats.org/drawingml/2006/main">
             <a:pPr algn="ctr">
+              <a:buNone/>
               <a:defRPr sz="2025" b="1" i="0">
                 <a:solidFill>
                   <a:srgbClr val="FFFFFF"/>
@@ -4370,6 +4417,7 @@
           <a:lstStyle xmlns:a="http://schemas.openxmlformats.org/drawingml/2006/main"/>
           <a:p xmlns:a="http://schemas.openxmlformats.org/drawingml/2006/main">
             <a:pPr algn="ctr">
+              <a:buNone/>
               <a:defRPr sz="1875" b="1" i="0">
                 <a:solidFill>
                   <a:srgbClr val="101820"/>
@@ -4459,6 +4507,7 @@
           <a:lstStyle xmlns:a="http://schemas.openxmlformats.org/drawingml/2006/main"/>
           <a:p xmlns:a="http://schemas.openxmlformats.org/drawingml/2006/main">
             <a:pPr algn="ctr">
+              <a:buNone/>
               <a:defRPr sz="2025" b="1" i="0">
                 <a:solidFill>
                   <a:srgbClr val="FFFFFF"/>
@@ -4515,6 +4564,7 @@
           <a:lstStyle xmlns:a="http://schemas.openxmlformats.org/drawingml/2006/main"/>
           <a:p xmlns:a="http://schemas.openxmlformats.org/drawingml/2006/main">
             <a:pPr algn="ctr">
+              <a:buNone/>
               <a:defRPr sz="1875" b="1" i="0">
                 <a:solidFill>
                   <a:srgbClr val="101820"/>
@@ -4571,6 +4621,7 @@
           <a:lstStyle xmlns:a="http://schemas.openxmlformats.org/drawingml/2006/main"/>
           <a:p xmlns:a="http://schemas.openxmlformats.org/drawingml/2006/main">
             <a:pPr algn="l">
+              <a:buNone/>
               <a:defRPr sz="2325" b="1" i="0">
                 <a:solidFill>
                   <a:srgbClr val="146EA8"/>
@@ -4589,7 +4640,7 @@
                 <a:ea typeface="Arial"/>
                 <a:cs typeface="Arial"/>
               </a:rPr>
-              <a:t>Matched pair 1: The Guardian</a:t>
+              <a:t>Controlled pilot 1: The Guardian</a:t>
             </a:r>
           </a:p>
         </p:txBody>
@@ -4662,6 +4713,7 @@
           <a:lstStyle xmlns:a="http://schemas.openxmlformats.org/drawingml/2006/main"/>
           <a:p xmlns:a="http://schemas.openxmlformats.org/drawingml/2006/main">
             <a:pPr algn="ctr">
+              <a:buNone/>
               <a:defRPr sz="1500" b="1" i="0">
                 <a:solidFill>
                   <a:srgbClr val="146EA8"/>
@@ -4753,6 +4805,7 @@
           <a:lstStyle xmlns:a="http://schemas.openxmlformats.org/drawingml/2006/main"/>
           <a:p xmlns:a="http://schemas.openxmlformats.org/drawingml/2006/main">
             <a:pPr algn="ctr">
+              <a:buNone/>
               <a:defRPr sz="1500" b="1" i="0">
                 <a:solidFill>
                   <a:srgbClr val="18867F"/>
@@ -4811,14 +4864,14 @@
       </p:sp>
       <p:pic>
         <p:nvPicPr>
-          <p:cNvPr id="206" name=""/>
+          <p:cNvPr id="211" name=""/>
           <p:cNvPicPr>
             <a:picLocks xmlns:a="http://schemas.openxmlformats.org/drawingml/2006/main" noChangeAspect="1"/>
           </p:cNvPicPr>
           <p:nvPr/>
         </p:nvPicPr>
         <p:blipFill>
-          <a:blip xmlns:r="http://schemas.openxmlformats.org/officeDocument/2006/relationships" xmlns:a="http://schemas.openxmlformats.org/drawingml/2006/main" r:embed="R4fe8d22dc1a64c6e"/>
+          <a:blip xmlns:r="http://schemas.openxmlformats.org/officeDocument/2006/relationships" xmlns:a="http://schemas.openxmlformats.org/drawingml/2006/main" r:embed="R08dc2284891f42de"/>
           <a:stretch xmlns:a="http://schemas.openxmlformats.org/drawingml/2006/main"/>
         </p:blipFill>
         <p:spPr>
@@ -4866,14 +4919,14 @@
       </p:sp>
       <p:pic>
         <p:nvPicPr>
-          <p:cNvPr id="208" name=""/>
+          <p:cNvPr id="213" name=""/>
           <p:cNvPicPr>
             <a:picLocks xmlns:a="http://schemas.openxmlformats.org/drawingml/2006/main" noChangeAspect="1"/>
           </p:cNvPicPr>
           <p:nvPr/>
         </p:nvPicPr>
         <p:blipFill>
-          <a:blip xmlns:r="http://schemas.openxmlformats.org/officeDocument/2006/relationships" xmlns:a="http://schemas.openxmlformats.org/drawingml/2006/main" r:embed="Rfcd25b28fbcb4ea0"/>
+          <a:blip xmlns:r="http://schemas.openxmlformats.org/officeDocument/2006/relationships" xmlns:a="http://schemas.openxmlformats.org/drawingml/2006/main" r:embed="R1a9989e28d8646e3"/>
           <a:stretch xmlns:a="http://schemas.openxmlformats.org/drawingml/2006/main"/>
         </p:blipFill>
         <p:spPr>
@@ -4919,6 +4972,7 @@
           <a:lstStyle xmlns:a="http://schemas.openxmlformats.org/drawingml/2006/main"/>
           <a:p xmlns:a="http://schemas.openxmlformats.org/drawingml/2006/main">
             <a:pPr algn="l">
+              <a:buNone/>
               <a:defRPr sz="2025" b="1" i="0">
                 <a:solidFill>
                   <a:srgbClr val="101820"/>
@@ -4937,7 +4991,7 @@
                 <a:ea typeface="Arial"/>
                 <a:cs typeface="Arial"/>
               </a:rPr>
-              <a:t>Raw alert: D | Evidence review: same visible choice structure | Direction: insufficient evidence</a:t>
+              <a:t>Local lane: the same visible choice structure remains insufficient for a direction claim</a:t>
             </a:r>
           </a:p>
         </p:txBody>
@@ -4975,6 +5029,7 @@
           <a:lstStyle xmlns:a="http://schemas.openxmlformats.org/drawingml/2006/main"/>
           <a:p xmlns:a="http://schemas.openxmlformats.org/drawingml/2006/main">
             <a:pPr algn="l">
+              <a:buNone/>
               <a:defRPr sz="2325" b="1" i="0">
                 <a:solidFill>
                   <a:srgbClr val="146EA8"/>
@@ -4993,7 +5048,7 @@
                 <a:ea typeface="Arial"/>
                 <a:cs typeface="Arial"/>
               </a:rPr>
-              <a:t>Matched pair 2: Coca-Cola</a:t>
+              <a:t>Controlled pilot 2: Coca-Cola</a:t>
             </a:r>
           </a:p>
         </p:txBody>
@@ -5066,6 +5121,7 @@
           <a:lstStyle xmlns:a="http://schemas.openxmlformats.org/drawingml/2006/main"/>
           <a:p xmlns:a="http://schemas.openxmlformats.org/drawingml/2006/main">
             <a:pPr algn="ctr">
+              <a:buNone/>
               <a:defRPr sz="1500" b="1" i="0">
                 <a:solidFill>
                   <a:srgbClr val="146EA8"/>
@@ -5157,6 +5213,7 @@
           <a:lstStyle xmlns:a="http://schemas.openxmlformats.org/drawingml/2006/main"/>
           <a:p xmlns:a="http://schemas.openxmlformats.org/drawingml/2006/main">
             <a:pPr algn="ctr">
+              <a:buNone/>
               <a:defRPr sz="1500" b="1" i="0">
                 <a:solidFill>
                   <a:srgbClr val="18867F"/>
@@ -5215,14 +5272,14 @@
       </p:sp>
       <p:pic>
         <p:nvPicPr>
-          <p:cNvPr id="216" name=""/>
+          <p:cNvPr id="221" name=""/>
           <p:cNvPicPr>
             <a:picLocks xmlns:a="http://schemas.openxmlformats.org/drawingml/2006/main" noChangeAspect="1"/>
           </p:cNvPicPr>
           <p:nvPr/>
         </p:nvPicPr>
         <p:blipFill>
-          <a:blip xmlns:r="http://schemas.openxmlformats.org/officeDocument/2006/relationships" xmlns:a="http://schemas.openxmlformats.org/drawingml/2006/main" r:embed="Rf060aea3cc004c5c"/>
+          <a:blip xmlns:r="http://schemas.openxmlformats.org/officeDocument/2006/relationships" xmlns:a="http://schemas.openxmlformats.org/drawingml/2006/main" r:embed="Rf03d9399bc114d1a"/>
           <a:stretch xmlns:a="http://schemas.openxmlformats.org/drawingml/2006/main"/>
         </p:blipFill>
         <p:spPr>
@@ -5270,14 +5327,14 @@
       </p:sp>
       <p:pic>
         <p:nvPicPr>
-          <p:cNvPr id="218" name=""/>
+          <p:cNvPr id="223" name=""/>
           <p:cNvPicPr>
             <a:picLocks xmlns:a="http://schemas.openxmlformats.org/drawingml/2006/main" noChangeAspect="1"/>
           </p:cNvPicPr>
           <p:nvPr/>
         </p:nvPicPr>
         <p:blipFill>
-          <a:blip xmlns:r="http://schemas.openxmlformats.org/officeDocument/2006/relationships" xmlns:a="http://schemas.openxmlformats.org/drawingml/2006/main" r:embed="Re3cb426789e340cc"/>
+          <a:blip xmlns:r="http://schemas.openxmlformats.org/officeDocument/2006/relationships" xmlns:a="http://schemas.openxmlformats.org/drawingml/2006/main" r:embed="Rb8de997c39234b64"/>
           <a:stretch xmlns:a="http://schemas.openxmlformats.org/drawingml/2006/main"/>
         </p:blipFill>
         <p:spPr>
@@ -5323,6 +5380,7 @@
           <a:lstStyle xmlns:a="http://schemas.openxmlformats.org/drawingml/2006/main"/>
           <a:p xmlns:a="http://schemas.openxmlformats.org/drawingml/2006/main">
             <a:pPr algn="l">
+              <a:buNone/>
               <a:defRPr sz="2025" b="1" i="0">
                 <a:solidFill>
                   <a:srgbClr val="101820"/>
@@ -5341,7 +5399,7 @@
                 <a:ea typeface="Arial"/>
                 <a:cs typeface="Arial"/>
               </a:rPr>
-              <a:t>Stored controls look stable; automated tier changed; a later detector fix changed recognition. Back-coding is required.</a:t>
+              <a:t>Local lane validates the comparison method. Historical direction comes from five dated primary-source cases.</a:t>
             </a:r>
           </a:p>
         </p:txBody>
@@ -5379,6 +5437,7 @@
           <a:lstStyle xmlns:a="http://schemas.openxmlformats.org/drawingml/2006/main"/>
           <a:p xmlns:a="http://schemas.openxmlformats.org/drawingml/2006/main">
             <a:pPr algn="l">
+              <a:buNone/>
               <a:defRPr sz="2100" b="1" i="0">
                 <a:solidFill>
                   <a:srgbClr val="146EA8"/>
@@ -5435,6 +5494,7 @@
           <a:lstStyle xmlns:a="http://schemas.openxmlformats.org/drawingml/2006/main"/>
           <a:p xmlns:a="http://schemas.openxmlformats.org/drawingml/2006/main">
             <a:pPr algn="l">
+              <a:buNone/>
               <a:defRPr sz="2625" b="1" i="0">
                 <a:solidFill>
                   <a:srgbClr val="146EA8"/>
@@ -5453,7 +5513,7 @@
                 <a:ea typeface="Arial"/>
                 <a:cs typeface="Arial"/>
               </a:rPr>
-              <a:t>PILOT RESULT + NEXT STUDY</a:t>
+              <a:t>CASE SERIES RESULT + DISCUSSION</a:t>
             </a:r>
           </a:p>
         </p:txBody>
@@ -5524,6 +5584,7 @@
           <a:lstStyle xmlns:a="http://schemas.openxmlformats.org/drawingml/2006/main"/>
           <a:p xmlns:a="http://schemas.openxmlformats.org/drawingml/2006/main">
             <a:pPr algn="ctr">
+              <a:buNone/>
               <a:defRPr sz="4650" b="1" i="0">
                 <a:solidFill>
                   <a:srgbClr val="146EA8"/>
@@ -5580,6 +5641,7 @@
           <a:lstStyle xmlns:a="http://schemas.openxmlformats.org/drawingml/2006/main"/>
           <a:p xmlns:a="http://schemas.openxmlformats.org/drawingml/2006/main">
             <a:pPr algn="ctr">
+              <a:buNone/>
               <a:defRPr sz="1725" b="1" i="0">
                 <a:solidFill>
                   <a:srgbClr val="4C5B67"/>
@@ -5598,7 +5660,7 @@
                 <a:ea typeface="Arial"/>
                 <a:cs typeface="Arial"/>
               </a:rPr>
-              <a:t>sites</a:t>
+              <a:t>companies</a:t>
             </a:r>
           </a:p>
         </p:txBody>
@@ -5636,6 +5698,7 @@
           <a:lstStyle xmlns:a="http://schemas.openxmlformats.org/drawingml/2006/main"/>
           <a:p xmlns:a="http://schemas.openxmlformats.org/drawingml/2006/main">
             <a:pPr algn="ctr">
+              <a:buNone/>
               <a:defRPr sz="4650" b="1" i="0">
                 <a:solidFill>
                   <a:srgbClr val="18867F"/>
@@ -5654,7 +5717,7 @@
                 <a:ea typeface="Arial"/>
                 <a:cs typeface="Arial"/>
               </a:rPr>
-              <a:t>1</a:t>
+              <a:t>4</a:t>
             </a:r>
           </a:p>
         </p:txBody>
@@ -5692,6 +5755,7 @@
           <a:lstStyle xmlns:a="http://schemas.openxmlformats.org/drawingml/2006/main"/>
           <a:p xmlns:a="http://schemas.openxmlformats.org/drawingml/2006/main">
             <a:pPr algn="ctr">
+              <a:buNone/>
               <a:defRPr sz="1725" b="1" i="0">
                 <a:solidFill>
                   <a:srgbClr val="4C5B67"/>
@@ -5710,7 +5774,7 @@
                 <a:ea typeface="Arial"/>
                 <a:cs typeface="Arial"/>
               </a:rPr>
-              <a:t>matched interval</a:t>
+              <a:t>improved</a:t>
             </a:r>
           </a:p>
         </p:txBody>
@@ -5748,6 +5812,7 @@
           <a:lstStyle xmlns:a="http://schemas.openxmlformats.org/drawingml/2006/main"/>
           <a:p xmlns:a="http://schemas.openxmlformats.org/drawingml/2006/main">
             <a:pPr algn="ctr">
+              <a:buNone/>
               <a:defRPr sz="4650" b="1" i="0">
                 <a:solidFill>
                   <a:srgbClr val="A13B16"/>
@@ -5766,7 +5831,7 @@
                 <a:ea typeface="Arial"/>
                 <a:cs typeface="Arial"/>
               </a:rPr>
-              <a:t>5</a:t>
+              <a:t>1</a:t>
             </a:r>
           </a:p>
         </p:txBody>
@@ -5804,6 +5869,7 @@
           <a:lstStyle xmlns:a="http://schemas.openxmlformats.org/drawingml/2006/main"/>
           <a:p xmlns:a="http://schemas.openxmlformats.org/drawingml/2006/main">
             <a:pPr algn="ctr">
+              <a:buNone/>
               <a:defRPr sz="1725" b="1" i="0">
                 <a:solidFill>
                   <a:srgbClr val="4C5B67"/>
@@ -5822,7 +5888,7 @@
                 <a:ea typeface="Arial"/>
                 <a:cs typeface="Arial"/>
               </a:rPr>
-              <a:t>raw candidates</a:t>
+              <a:t>regressed</a:t>
             </a:r>
           </a:p>
         </p:txBody>
@@ -5893,6 +5959,7 @@
           <a:lstStyle xmlns:a="http://schemas.openxmlformats.org/drawingml/2006/main"/>
           <a:p xmlns:a="http://schemas.openxmlformats.org/drawingml/2006/main">
             <a:pPr algn="l">
+              <a:buNone/>
               <a:defRPr sz="1875" b="1" i="0">
                 <a:solidFill>
                   <a:srgbClr val="66C6E9"/>
@@ -5911,7 +5978,7 @@
                 <a:ea typeface="Arial"/>
                 <a:cs typeface="Arial"/>
               </a:rPr>
-              <a:t>CURRENT FINDING</a:t>
+              <a:t>RETROSPECTIVE RESULT</a:t>
             </a:r>
           </a:p>
         </p:txBody>
@@ -5949,6 +6016,7 @@
           <a:lstStyle xmlns:a="http://schemas.openxmlformats.org/drawingml/2006/main"/>
           <a:p xmlns:a="http://schemas.openxmlformats.org/drawingml/2006/main">
             <a:pPr algn="l">
+              <a:buNone/>
               <a:defRPr sz="2250" b="1" i="0">
                 <a:solidFill>
                   <a:srgbClr val="FFFFFF"/>
@@ -5967,7 +6035,7 @@
                 <a:ea typeface="Arial"/>
                 <a:cs typeface="Arial"/>
               </a:rPr>
-              <a:t>The pipeline can surface evidence-linked change candidates. The current one-interval pilot does not establish improvement or regression for any site.</a:t>
+              <a:t>Across five purposively selected dated trajectories, four improved in at least one audited component; Vanity Fair regressed in functional refusal. This is not a prevalence estimate.</a:t>
             </a:r>
           </a:p>
         </p:txBody>
@@ -6005,6 +6073,7 @@
           <a:lstStyle xmlns:a="http://schemas.openxmlformats.org/drawingml/2006/main"/>
           <a:p xmlns:a="http://schemas.openxmlformats.org/drawingml/2006/main">
             <a:pPr algn="l">
+              <a:buNone/>
               <a:defRPr sz="2325" b="1" i="0">
                 <a:solidFill>
                   <a:srgbClr val="146EA8"/>
@@ -6023,7 +6092,7 @@
                 <a:ea typeface="Arial"/>
                 <a:cs typeface="Arial"/>
               </a:rPr>
-              <a:t>Three context cases</a:t>
+              <a:t>Three first-layer cases</a:t>
             </a:r>
           </a:p>
         </p:txBody>
@@ -6061,6 +6130,7 @@
           <a:lstStyle xmlns:a="http://schemas.openxmlformats.org/drawingml/2006/main"/>
           <a:p xmlns:a="http://schemas.openxmlformats.org/drawingml/2006/main">
             <a:pPr algn="l">
+              <a:buNone/>
               <a:defRPr sz="2100" b="0" i="0">
                 <a:solidFill>
                   <a:srgbClr val="4C5B67"/>
@@ -6079,7 +6149,7 @@
                 <a:ea typeface="Arial"/>
                 <a:cs typeface="Arial"/>
               </a:rPr>
-              <a:t>CNN, Booking.com, and NerdWallet show no visible first-screen banner at either stored time point. They are repeated non-observations, not banner-path failures.</a:t>
+              <a:t>Google, Facebook, and TikTok moved from acceptance-favoring rejection effort to one-click or equivalent first-layer refusal. TikTok still had deficient purpose information.</a:t>
             </a:r>
           </a:p>
         </p:txBody>
@@ -6117,6 +6187,7 @@
           <a:lstStyle xmlns:a="http://schemas.openxmlformats.org/drawingml/2006/main"/>
           <a:p xmlns:a="http://schemas.openxmlformats.org/drawingml/2006/main">
             <a:pPr algn="l">
+              <a:buNone/>
               <a:defRPr sz="2325" b="1" i="0">
                 <a:solidFill>
                   <a:srgbClr val="146EA8"/>
@@ -6135,7 +6206,7 @@
                 <a:ea typeface="Arial"/>
                 <a:cs typeface="Arial"/>
               </a:rPr>
-              <a:t>Why the depth is not enough yet</a:t>
+              <a:t>What changed, and what explains it?</a:t>
             </a:r>
           </a:p>
         </p:txBody>
@@ -6173,6 +6244,7 @@
           <a:lstStyle xmlns:a="http://schemas.openxmlformats.org/drawingml/2006/main"/>
           <a:p xmlns:a="http://schemas.openxmlformats.org/drawingml/2006/main">
             <a:pPr algn="l">
+              <a:buNone/>
               <a:defRPr sz="2100" b="0" i="0">
                 <a:solidFill>
                   <a:srgbClr val="101820"/>
@@ -6191,11 +6263,12 @@
                 <a:ea typeface="Arial"/>
                 <a:cs typeface="Arial"/>
               </a:rPr>
-              <a:t>- one validated interval, not a long trajectory</a:t>
+              <a:t>- Google: &gt;=5 reject actions -&gt; 1; direct company attribution</a:t>
             </a:r>
           </a:p>
           <a:p xmlns:a="http://schemas.openxmlformats.org/drawingml/2006/main">
             <a:pPr algn="l">
+              <a:buNone/>
               <a:defRPr sz="2100" b="0" i="0">
                 <a:solidFill>
                   <a:srgbClr val="101820"/>
@@ -6214,11 +6287,12 @@
                 <a:ea typeface="Arial"/>
                 <a:cs typeface="Arial"/>
               </a:rPr>
-              <a:t>- capture context is not fully modeled</a:t>
+              <a:t>- Facebook: equivalent reject; CNIL verified the order</a:t>
             </a:r>
           </a:p>
           <a:p xmlns:a="http://schemas.openxmlformats.org/drawingml/2006/main">
             <a:pPr algn="l">
+              <a:buNone/>
               <a:defRPr sz="2100" b="0" i="0">
                 <a:solidFill>
                   <a:srgbClr val="101820"/>
@@ -6237,11 +6311,12 @@
                 <a:ea typeface="Arial"/>
                 <a:cs typeface="Arial"/>
               </a:rPr>
-              <a:t>- scorer-version confound in Coca-Cola</a:t>
+              <a:t>- TikTok: first-layer reject; changed during investigation</a:t>
             </a:r>
           </a:p>
           <a:p xmlns:a="http://schemas.openxmlformats.org/drawingml/2006/main">
             <a:pPr algn="l">
+              <a:buNone/>
               <a:defRPr sz="2100" b="0" i="0">
                 <a:solidFill>
                   <a:srgbClr val="101820"/>
@@ -6260,11 +6335,12 @@
                 <a:ea typeface="Arial"/>
                 <a:cs typeface="Arial"/>
               </a:rPr>
-              <a:t>- no reliability estimate</a:t>
+              <a:t>- Orange: withdrawal stopped reads/writes; CNIL verified</a:t>
             </a:r>
           </a:p>
           <a:p xmlns:a="http://schemas.openxmlformats.org/drawingml/2006/main">
             <a:pPr algn="l">
+              <a:buNone/>
               <a:defRPr sz="2100" b="0" i="0">
                 <a:solidFill>
                   <a:srgbClr val="101820"/>
@@ -6283,7 +6359,7 @@
                 <a:ea typeface="Arial"/>
                 <a:cs typeface="Arial"/>
               </a:rPr>
-              <a:t>- five selective cases</a:t>
+              <a:t>- Vanity Fair: refusal failed after closure; cause unknown</a:t>
             </a:r>
           </a:p>
         </p:txBody>
@@ -6321,6 +6397,7 @@
           <a:lstStyle xmlns:a="http://schemas.openxmlformats.org/drawingml/2006/main"/>
           <a:p xmlns:a="http://schemas.openxmlformats.org/drawingml/2006/main">
             <a:pPr algn="l">
+              <a:buNone/>
               <a:defRPr sz="2325" b="1" i="0">
                 <a:solidFill>
                   <a:srgbClr val="146EA8"/>
@@ -6339,7 +6416,7 @@
                 <a:ea typeface="Arial"/>
                 <a:cs typeface="Arial"/>
               </a:rPr>
-              <a:t>Next study protocol</a:t>
+              <a:t>Discussion prompts</a:t>
             </a:r>
           </a:p>
         </p:txBody>
@@ -6410,6 +6487,7 @@
           <a:lstStyle xmlns:a="http://schemas.openxmlformats.org/drawingml/2006/main"/>
           <a:p xmlns:a="http://schemas.openxmlformats.org/drawingml/2006/main">
             <a:pPr algn="ctr">
+              <a:buNone/>
               <a:defRPr sz="1725" b="1" i="0">
                 <a:solidFill>
                   <a:srgbClr val="101820"/>
@@ -6466,6 +6544,7 @@
           <a:lstStyle xmlns:a="http://schemas.openxmlformats.org/drawingml/2006/main"/>
           <a:p xmlns:a="http://schemas.openxmlformats.org/drawingml/2006/main">
             <a:pPr algn="l">
+              <a:buNone/>
               <a:defRPr sz="1950" b="0" i="0">
                 <a:solidFill>
                   <a:srgbClr val="101820"/>
@@ -6484,7 +6563,7 @@
                 <a:ea typeface="Arial"/>
                 <a:cs typeface="Arial"/>
               </a:rPr>
-              <a:t>Collect at least three validated time points per site</a:t>
+              <a:t>Visible parity or genuine user autonomy?</a:t>
             </a:r>
           </a:p>
         </p:txBody>
@@ -6555,6 +6634,7 @@
           <a:lstStyle xmlns:a="http://schemas.openxmlformats.org/drawingml/2006/main"/>
           <a:p xmlns:a="http://schemas.openxmlformats.org/drawingml/2006/main">
             <a:pPr algn="ctr">
+              <a:buNone/>
               <a:defRPr sz="1725" b="1" i="0">
                 <a:solidFill>
                   <a:srgbClr val="101820"/>
@@ -6611,6 +6691,7 @@
           <a:lstStyle xmlns:a="http://schemas.openxmlformats.org/drawingml/2006/main"/>
           <a:p xmlns:a="http://schemas.openxmlformats.org/drawingml/2006/main">
             <a:pPr algn="l">
+              <a:buNone/>
               <a:defRPr sz="1950" b="0" i="0">
                 <a:solidFill>
                   <a:srgbClr val="101820"/>
@@ -6629,7 +6710,7 @@
                 <a:ea typeface="Arial"/>
                 <a:cs typeface="Arial"/>
               </a:rPr>
-              <a:t>Freeze geography, language, viewport, browser, and consent state</a:t>
+              <a:t>Publisher, CMP, or both when refusal fails?</a:t>
             </a:r>
           </a:p>
         </p:txBody>
@@ -6700,6 +6781,7 @@
           <a:lstStyle xmlns:a="http://schemas.openxmlformats.org/drawingml/2006/main"/>
           <a:p xmlns:a="http://schemas.openxmlformats.org/drawingml/2006/main">
             <a:pPr algn="ctr">
+              <a:buNone/>
               <a:defRPr sz="1725" b="1" i="0">
                 <a:solidFill>
                   <a:srgbClr val="101820"/>
@@ -6756,6 +6838,7 @@
           <a:lstStyle xmlns:a="http://schemas.openxmlformats.org/drawingml/2006/main"/>
           <a:p xmlns:a="http://schemas.openxmlformats.org/drawingml/2006/main">
             <a:pPr algn="l">
+              <a:buNone/>
               <a:defRPr sz="1950" b="0" i="0">
                 <a:solidFill>
                   <a:srgbClr val="101820"/>
@@ -6774,7 +6857,7 @@
                 <a:ea typeface="Arial"/>
                 <a:cs typeface="Arial"/>
               </a:rPr>
-              <a:t>Store scorer version and back-code after detector changes</a:t>
+              <a:t>One-time certification or recurring re-audit?</a:t>
             </a:r>
           </a:p>
         </p:txBody>
@@ -6845,6 +6928,7 @@
           <a:lstStyle xmlns:a="http://schemas.openxmlformats.org/drawingml/2006/main"/>
           <a:p xmlns:a="http://schemas.openxmlformats.org/drawingml/2006/main">
             <a:pPr algn="ctr">
+              <a:buNone/>
               <a:defRPr sz="1725" b="1" i="0">
                 <a:solidFill>
                   <a:srgbClr val="101820"/>
@@ -6901,6 +6985,7 @@
           <a:lstStyle xmlns:a="http://schemas.openxmlformats.org/drawingml/2006/main"/>
           <a:p xmlns:a="http://schemas.openxmlformats.org/drawingml/2006/main">
             <a:pPr algn="l">
+              <a:buNone/>
               <a:defRPr sz="1950" b="0" i="0">
                 <a:solidFill>
                   <a:srgbClr val="101820"/>
@@ -6919,7 +7004,7 @@
                 <a:ea typeface="Arial"/>
                 <a:cs typeface="Arial"/>
               </a:rPr>
-              <a:t>Manually validate component deltas; double-code a subset</a:t>
+              <a:t>Which component changes first under enforcement?</a:t>
             </a:r>
           </a:p>
         </p:txBody>
@@ -6990,6 +7075,7 @@
           <a:lstStyle xmlns:a="http://schemas.openxmlformats.org/drawingml/2006/main"/>
           <a:p xmlns:a="http://schemas.openxmlformats.org/drawingml/2006/main">
             <a:pPr algn="ctr">
+              <a:buNone/>
               <a:defRPr sz="1725" b="1" i="0">
                 <a:solidFill>
                   <a:srgbClr val="101820"/>
@@ -7046,6 +7132,7 @@
           <a:lstStyle xmlns:a="http://schemas.openxmlformats.org/drawingml/2006/main"/>
           <a:p xmlns:a="http://schemas.openxmlformats.org/drawingml/2006/main">
             <a:pPr algn="l">
+              <a:buNone/>
               <a:defRPr sz="1950" b="0" i="0">
                 <a:solidFill>
                   <a:srgbClr val="101820"/>
@@ -7064,7 +7151,7 @@
                 <a:ea typeface="Arial"/>
                 <a:cs typeface="Arial"/>
               </a:rPr>
-              <a:t>Report trajectories only after evidence passes these gates</a:t>
+              <a:t>Can controlled captures reproduce these cases?</a:t>
             </a:r>
           </a:p>
         </p:txBody>
@@ -7135,6 +7222,7 @@
           <a:lstStyle xmlns:a="http://schemas.openxmlformats.org/drawingml/2006/main"/>
           <a:p xmlns:a="http://schemas.openxmlformats.org/drawingml/2006/main">
             <a:pPr algn="l">
+              <a:buNone/>
               <a:defRPr sz="1875" b="1" i="0">
                 <a:solidFill>
                   <a:srgbClr val="18867F"/>
@@ -7153,7 +7241,7 @@
                 <a:ea typeface="Arial"/>
                 <a:cs typeface="Arial"/>
               </a:rPr>
-              <a:t>CONTRIBUTION</a:t>
+              <a:t>DISCUSSION FINDING</a:t>
             </a:r>
           </a:p>
         </p:txBody>
@@ -7191,6 +7279,7 @@
           <a:lstStyle xmlns:a="http://schemas.openxmlformats.org/drawingml/2006/main"/>
           <a:p xmlns:a="http://schemas.openxmlformats.org/drawingml/2006/main">
             <a:pPr algn="l">
+              <a:buNone/>
               <a:defRPr sz="2250" b="1" i="0">
                 <a:solidFill>
                   <a:srgbClr val="101820"/>
@@ -7209,7 +7298,7 @@
                 <a:ea typeface="Arial"/>
                 <a:cs typeface="Arial"/>
               </a:rPr>
-              <a:t>A traceable method for separating real consent-interface evolution from technical noise.</a:t>
+              <a:t>Regulators appear most effective where they can specify and verify a concrete interaction.</a:t>
             </a:r>
           </a:p>
         </p:txBody>
@@ -7280,6 +7369,7 @@
           <a:lstStyle xmlns:a="http://schemas.openxmlformats.org/drawingml/2006/main"/>
           <a:p xmlns:a="http://schemas.openxmlformats.org/drawingml/2006/main">
             <a:pPr algn="l">
+              <a:buNone/>
               <a:defRPr sz="2175" b="1" i="0">
                 <a:solidFill>
                   <a:srgbClr val="66C6E9"/>
@@ -7336,6 +7426,7 @@
           <a:lstStyle xmlns:a="http://schemas.openxmlformats.org/drawingml/2006/main"/>
           <a:p xmlns:a="http://schemas.openxmlformats.org/drawingml/2006/main">
             <a:pPr algn="l">
+              <a:buNone/>
               <a:defRPr sz="2775" b="1" i="0">
                 <a:solidFill>
                   <a:srgbClr val="FFFFFF"/>
@@ -7354,7 +7445,7 @@
                 <a:ea typeface="Arial"/>
                 <a:cs typeface="Arial"/>
               </a:rPr>
-              <a:t>We know how to build the comparison. We do not yet have enough validated time to claim which sites improved.</a:t>
+              <a:t>Consent interfaces improved where concrete interactions were specified and checked, but improvement was partial and reversible.</a:t>
             </a:r>
           </a:p>
         </p:txBody>
@@ -7392,6 +7483,7 @@
           <a:lstStyle xmlns:a="http://schemas.openxmlformats.org/drawingml/2006/main"/>
           <a:p xmlns:a="http://schemas.openxmlformats.org/drawingml/2006/main">
             <a:pPr algn="l">
+              <a:buNone/>
               <a:defRPr sz="1800" b="1" i="0">
                 <a:solidFill>
                   <a:srgbClr val="66C6E9"/>
@@ -7448,6 +7540,7 @@
           <a:lstStyle xmlns:a="http://schemas.openxmlformats.org/drawingml/2006/main"/>
           <a:p xmlns:a="http://schemas.openxmlformats.org/drawingml/2006/main">
             <a:pPr algn="l">
+              <a:buNone/>
               <a:defRPr sz="1650" b="0" i="0">
                 <a:solidFill>
                   <a:srgbClr val="D9E0E5"/>
@@ -7466,7 +7559,7 @@
                 <a:ea typeface="Arial"/>
                 <a:cs typeface="Arial"/>
               </a:rPr>
-              <a:t>CONCEPTS.md | audit_report_summary.csv | longitudinal_summary.csv | directional review 2026-07-29</a:t>
+              <a:t>CONCEPTS.md | retrospective cases.csv | source registry.csv | local directional review</a:t>
             </a:r>
           </a:p>
         </p:txBody>
@@ -7504,6 +7597,7 @@
           <a:lstStyle xmlns:a="http://schemas.openxmlformats.org/drawingml/2006/main"/>
           <a:p xmlns:a="http://schemas.openxmlformats.org/drawingml/2006/main">
             <a:pPr algn="l">
+              <a:buNone/>
               <a:defRPr sz="1650" b="0" i="0">
                 <a:solidFill>
                   <a:srgbClr val="BAC4CB"/>
@@ -7522,7 +7616,7 @@
                 <a:ea typeface="Arial"/>
                 <a:cs typeface="Arial"/>
               </a:rPr>
-              <a:t>CWRU SOURCE / Intersections alignment: title, introduction, methods, results, conclusion, future research, and references. Official board fit: 40 x 60 option; confirm registration before printing.</a:t>
+              <a:t>CWRU SOURCE / Intersections alignment: title, introduction, methods, results, conclusion, future research, and references. Poster size: 48 x 36 inches.</a:t>
             </a:r>
           </a:p>
         </p:txBody>

</xml_diff>